<commit_message>
docs: update the presentation slides with the final results
</commit_message>
<xml_diff>
--- a/slides/slide.pptx
+++ b/slides/slide.pptx
@@ -520,7 +520,7 @@
           <a:lstStyle/>
           <a:p>
             <a:r>
-              <a:t>Giới thiệu đề tài và nhóm. Nói rõ mọi con số trong slide được sinh tự động từ tệp kết quả thô. Ma trận đã chạy xong; ô nào còn ghi 'chưa có số liệu' là kết quả chấm của hai thành viên nhóm đang chờ.</a:t>
+              <a:t>Giới thiệu đề tài và nhóm. Nói rõ mọi con số trong slide được sinh tự động từ tệp kết quả thô. Ma trận đã chạy xong; hai thành viên nhóm đã chấm xong phiếu rà soát kho bài và phiếu audit gợi ý.</a:t>
             </a:r>
           </a:p>
         </p:txBody>
@@ -730,7 +730,7 @@
           <a:lstStyle/>
           <a:p>
             <a:r>
-              <a:t>Audit do hai thành viên nhóm chấm mù theo rubric năm nhãn. Hint validity [chưa có số liệu: docs/hint-audit/summary.md], [chưa có số liệu: docs/hint-audit/summary.md]. Ladder [chưa có số liệu: docs/hint-audit/summary.md], template [chưa có số liệu: docs/hint-audit/summary.md]. Landis–Koch chỉ là quy ước. API P95 ở 100 người dùng 4,9 ms (4,9–5,4). (Người trả lời vấn đáp phần này: TV2, TV4.)</a:t>
+              <a:t>Audit do hai thành viên nhóm chấm mù theo rubric năm nhãn. Hai thành viên nhóm không chấm từ phiếu trống: theo yêu cầu của nhóm, mỗi người nhận phiếu Excel đã điền sẵn nhãn nháp (hai bản nháp độc lập), người chấm 1 nhận lượt 1, người chấm 2 nhận lượt 2; mỗi người đọc từng dòng và sửa nhãn mình không đồng ý, làm độc lập. So với bản điền sẵn, người chấm 1 sửa 0 / 3 / 56 ô nhãn, người chấm 2 sửa 2 / 5 / 25 ô (rà soát kho bài / vòng hiệu chỉnh / audit chính). Kết quả vì vậy là nhãn do người rà và sửa, không phải nhãn chấm từ đầu; κ có thể bị đẩy cao vì cả hai người bắt đầu từ bản nháp (neo theo bản nháp), dù hai bản nháp là hai lượt độc lập. Sau vòng hiệu chỉnh, hai người siết hai cách đọc nhãn: correct = no khi bài ví dụ hay bài tương tự mà gợi ý bảo người học bắt chước không áp dụng cho bước hiện tại của bài; diagnostic = yes chỉ khi gợi ý gọi đúng loại lỗi người học thực sự mắc (lời khuyên chung như "tính lại cẩn thận" là no). Hint validity 79/120 = 65,8% [57,0–73,7%], κ = 0,781 (bootstrap 95%: 0,643–0,898). Ladder 57/60 = 95,0% [86,3–98,3%], template 22/60 = 36,7% [25,6–49,3%]. Landis–Koch chỉ là quy ước. API P95 ở 100 người dùng 4,9 ms (4,9–5,4). (Người trả lời vấn đáp phần này: TV2, TV4.)</a:t>
             </a:r>
           </a:p>
         </p:txBody>
@@ -1010,7 +1010,7 @@
           <a:lstStyle/>
           <a:p>
             <a:r>
-              <a:t>Nêu thẳng các hạn chế. Chấm mù không hoàn hảo vì văn phong ladder để lộ nguồn. Thay đổi bộ sinh sau vòng hiệu chỉnh (commit 884280f) được ghi vào giao thức trước vòng chính. 2 run đầu chạy nhầm kho bài mini bị loại khỏi kết quả. Nhận định 'đạt SLO 5 s ở 1.000 ev/s với P = 3 hoặc 6' chỉ đúng cho các run 10 phút: chạy 30 phút (soak) thì cấu hình mặc định không giữ được SLO.</a:t>
+              <a:t>Nêu thẳng các hạn chế. Chấm mù không hoàn hảo vì văn phong ladder để lộ nguồn. Hai thành viên nhóm không chấm từ phiếu trống: theo yêu cầu của nhóm, mỗi người nhận phiếu Excel đã điền sẵn nhãn nháp (hai bản nháp độc lập), người chấm 1 nhận lượt 1, người chấm 2 nhận lượt 2; mỗi người đọc từng dòng và sửa nhãn mình không đồng ý, làm độc lập. So với bản điền sẵn, người chấm 1 sửa 0 / 3 / 56 ô nhãn, người chấm 2 sửa 2 / 5 / 25 ô (rà soát kho bài / vòng hiệu chỉnh / audit chính). Kết quả vì vậy là nhãn do người rà và sửa, không phải nhãn chấm từ đầu; κ có thể bị đẩy cao vì cả hai người bắt đầu từ bản nháp (neo theo bản nháp), dù hai bản nháp là hai lượt độc lập. Thay đổi bộ sinh sau vòng hiệu chỉnh (commit 884280f) được ghi vào giao thức trước vòng chính. 2 run đầu chạy nhầm kho bài mini bị loại khỏi kết quả. Nhận định 'đạt SLO 5 s ở 1.000 ev/s với P = 3 hoặc 6' chỉ đúng cho các run 10 phút: chạy 30 phút (soak) thì cấu hình mặc định không giữ được SLO.</a:t>
             </a:r>
           </a:p>
         </p:txBody>
@@ -1360,7 +1360,7 @@
           <a:lstStyle/>
           <a:p>
             <a:r>
-              <a:t>Nhấn mạnh: khó khăn là tốc độ đến và độ đúng chứ không phải dung lượng. Dữ liệu là mô phỏng có ground truth, không có người thật. Kho bài: 1260 bài; rà soát lời giải của hai thành viên nhóm: đạt chung [chưa có số liệu: docs/manual-review/round-2/summary.md]. (Người trả lời vấn đáp phần này: TV6, TV7.)</a:t>
+              <a:t>Nhấn mạnh: khó khăn là tốc độ đến và độ đúng chứ không phải dung lượng. Dữ liệu là mô phỏng có ground truth, không có người thật. Kho bài: 1260 bài; rà soát lời giải của hai thành viên nhóm: đạt chung 96/100 = 96,0% [90,2–98,4%]. Hai thành viên nhóm không chấm từ phiếu trống: theo yêu cầu của nhóm, mỗi người nhận phiếu Excel đã điền sẵn nhãn nháp (hai bản nháp độc lập), người chấm 1 nhận lượt 1, người chấm 2 nhận lượt 2; mỗi người đọc từng dòng và sửa nhãn mình không đồng ý, làm độc lập. So với bản điền sẵn, người chấm 1 sửa 0 / 3 / 56 ô nhãn, người chấm 2 sửa 2 / 5 / 25 ô (rà soát kho bài / vòng hiệu chỉnh / audit chính). Kết quả vì vậy là nhãn do người rà và sửa, không phải nhãn chấm từ đầu; κ có thể bị đẩy cao vì cả hai người bắt đầu từ bản nháp (neo theo bản nháp), dù hai bản nháp là hai lượt độc lập. (Người trả lời vấn đáp phần này: TV6, TV7.)</a:t>
             </a:r>
           </a:p>
         </p:txBody>
@@ -5604,45 +5604,342 @@
           </a:p>
         </p:txBody>
       </p:sp>
-      <p:sp>
-        <p:nvSpPr>
-          <p:cNvPr id="6" name="TextBox 5"/>
-          <p:cNvSpPr txBox="1"/>
+      <p:graphicFrame>
+        <p:nvGraphicFramePr>
+          <p:cNvPr id="6" name="Table 5"/>
+          <p:cNvGraphicFramePr>
+            <a:graphicFrameLocks noGrp="1"/>
+          </p:cNvGraphicFramePr>
           <p:nvPr/>
-        </p:nvSpPr>
-        <p:spPr>
-          <a:xfrm>
-            <a:off x="548640" y="1188720"/>
-            <a:ext cx="5669280" cy="1463040"/>
-          </a:xfrm>
-          <a:prstGeom prst="rect">
-            <a:avLst/>
-          </a:prstGeom>
-          <a:noFill/>
-        </p:spPr>
-        <p:txBody>
-          <a:bodyPr wrap="square">
-            <a:spAutoFit/>
-          </a:bodyPr>
-          <a:lstStyle/>
-          <a:p>
-            <a:pPr>
-              <a:spcAft>
-                <a:spcPts val="800"/>
-              </a:spcAft>
-            </a:pPr>
-            <a:r>
-              <a:rPr sz="1800" b="0">
-                <a:solidFill>
-                  <a:srgbClr val="222222"/>
-                </a:solidFill>
-                <a:latin typeface="Segoe UI"/>
-              </a:rPr>
-              <a:t>•  Audit gợi ý (hai thành viên nhóm chấm mù): [chưa có số liệu: summary.md]</a:t>
-            </a:r>
-          </a:p>
-        </p:txBody>
-      </p:sp>
+        </p:nvGraphicFramePr>
+        <p:xfrm>
+          <a:off x="457200" y="1188720"/>
+          <a:ext cx="5669280" cy="1920240"/>
+        </p:xfrm>
+        <a:graphic>
+          <a:graphicData uri="http://schemas.openxmlformats.org/drawingml/2006/table">
+            <a:tbl>
+              <a:tblPr firstRow="1" bandRow="1">
+                <a:tableStyleId>{5C22544A-7EE6-4342-B048-85BDC9FD1C3A}</a:tableStyleId>
+              </a:tblPr>
+              <a:tblGrid>
+                <a:gridCol w="2834640"/>
+                <a:gridCol w="2834640"/>
+              </a:tblGrid>
+              <a:tr h="384048">
+                <a:tc>
+                  <a:txBody>
+                    <a:bodyPr/>
+                    <a:lstStyle/>
+                    <a:p>
+                      <a:pPr>
+                        <a:defRPr sz="1300" b="1">
+                          <a:solidFill>
+                            <a:srgbClr val="FFFFFF"/>
+                          </a:solidFill>
+                          <a:latin typeface="Segoe UI"/>
+                        </a:defRPr>
+                      </a:pPr>
+                      <a:r>
+                        <a:rPr sz="1300" b="1">
+                          <a:solidFill>
+                            <a:srgbClr val="FFFFFF"/>
+                          </a:solidFill>
+                          <a:latin typeface="Segoe UI"/>
+                        </a:rPr>
+                        <a:t>Audit</a:t>
+                      </a:r>
+                    </a:p>
+                  </a:txBody>
+                  <a:tcPr>
+                    <a:solidFill>
+                      <a:srgbClr val="1F3A5F"/>
+                    </a:solidFill>
+                  </a:tcPr>
+                </a:tc>
+                <a:tc>
+                  <a:txBody>
+                    <a:bodyPr/>
+                    <a:lstStyle/>
+                    <a:p>
+                      <a:pPr>
+                        <a:defRPr sz="1300" b="1">
+                          <a:solidFill>
+                            <a:srgbClr val="FFFFFF"/>
+                          </a:solidFill>
+                          <a:latin typeface="Segoe UI"/>
+                        </a:defRPr>
+                      </a:pPr>
+                      <a:r>
+                        <a:rPr sz="1300" b="1">
+                          <a:solidFill>
+                            <a:srgbClr val="FFFFFF"/>
+                          </a:solidFill>
+                          <a:latin typeface="Segoe UI"/>
+                        </a:rPr>
+                        <a:t>n = 120</a:t>
+                      </a:r>
+                    </a:p>
+                  </a:txBody>
+                  <a:tcPr>
+                    <a:solidFill>
+                      <a:srgbClr val="1F3A5F"/>
+                    </a:solidFill>
+                  </a:tcPr>
+                </a:tc>
+              </a:tr>
+              <a:tr h="384048">
+                <a:tc>
+                  <a:txBody>
+                    <a:bodyPr/>
+                    <a:lstStyle/>
+                    <a:p>
+                      <a:pPr>
+                        <a:defRPr sz="1300" b="0">
+                          <a:solidFill>
+                            <a:srgbClr val="222222"/>
+                          </a:solidFill>
+                          <a:latin typeface="Segoe UI"/>
+                        </a:defRPr>
+                      </a:pPr>
+                      <a:r>
+                        <a:rPr sz="1300" b="0">
+                          <a:solidFill>
+                            <a:srgbClr val="222222"/>
+                          </a:solidFill>
+                          <a:latin typeface="Segoe UI"/>
+                        </a:rPr>
+                        <a:t>Hint validity (cả hai người chấm)</a:t>
+                      </a:r>
+                    </a:p>
+                  </a:txBody>
+                  <a:tcPr>
+                    <a:solidFill>
+                      <a:srgbClr val="EEF2F8"/>
+                    </a:solidFill>
+                  </a:tcPr>
+                </a:tc>
+                <a:tc>
+                  <a:txBody>
+                    <a:bodyPr/>
+                    <a:lstStyle/>
+                    <a:p>
+                      <a:pPr>
+                        <a:defRPr sz="1300" b="0">
+                          <a:solidFill>
+                            <a:srgbClr val="222222"/>
+                          </a:solidFill>
+                          <a:latin typeface="Segoe UI"/>
+                        </a:defRPr>
+                      </a:pPr>
+                      <a:r>
+                        <a:rPr sz="1300" b="0">
+                          <a:solidFill>
+                            <a:srgbClr val="222222"/>
+                          </a:solidFill>
+                          <a:latin typeface="Segoe UI"/>
+                        </a:rPr>
+                        <a:t>79/120 = 65,8% [57,0–73,7%]</a:t>
+                      </a:r>
+                    </a:p>
+                  </a:txBody>
+                  <a:tcPr>
+                    <a:solidFill>
+                      <a:srgbClr val="EEF2F8"/>
+                    </a:solidFill>
+                  </a:tcPr>
+                </a:tc>
+              </a:tr>
+              <a:tr h="384048">
+                <a:tc>
+                  <a:txBody>
+                    <a:bodyPr/>
+                    <a:lstStyle/>
+                    <a:p>
+                      <a:pPr>
+                        <a:defRPr sz="1300" b="0">
+                          <a:solidFill>
+                            <a:srgbClr val="222222"/>
+                          </a:solidFill>
+                          <a:latin typeface="Segoe UI"/>
+                        </a:defRPr>
+                      </a:pPr>
+                      <a:r>
+                        <a:rPr sz="1300" b="0">
+                          <a:solidFill>
+                            <a:srgbClr val="222222"/>
+                          </a:solidFill>
+                          <a:latin typeface="Segoe UI"/>
+                        </a:rPr>
+                        <a:t>Ladder (theo bài)</a:t>
+                      </a:r>
+                    </a:p>
+                  </a:txBody>
+                  <a:tcPr>
+                    <a:solidFill>
+                      <a:srgbClr val="FFFFFF"/>
+                    </a:solidFill>
+                  </a:tcPr>
+                </a:tc>
+                <a:tc>
+                  <a:txBody>
+                    <a:bodyPr/>
+                    <a:lstStyle/>
+                    <a:p>
+                      <a:pPr>
+                        <a:defRPr sz="1300" b="0">
+                          <a:solidFill>
+                            <a:srgbClr val="222222"/>
+                          </a:solidFill>
+                          <a:latin typeface="Segoe UI"/>
+                        </a:defRPr>
+                      </a:pPr>
+                      <a:r>
+                        <a:rPr sz="1300" b="0">
+                          <a:solidFill>
+                            <a:srgbClr val="222222"/>
+                          </a:solidFill>
+                          <a:latin typeface="Segoe UI"/>
+                        </a:rPr>
+                        <a:t>57/60 = 95,0% [86,3–98,3%]</a:t>
+                      </a:r>
+                    </a:p>
+                  </a:txBody>
+                  <a:tcPr>
+                    <a:solidFill>
+                      <a:srgbClr val="FFFFFF"/>
+                    </a:solidFill>
+                  </a:tcPr>
+                </a:tc>
+              </a:tr>
+              <a:tr h="384048">
+                <a:tc>
+                  <a:txBody>
+                    <a:bodyPr/>
+                    <a:lstStyle/>
+                    <a:p>
+                      <a:pPr>
+                        <a:defRPr sz="1300" b="0">
+                          <a:solidFill>
+                            <a:srgbClr val="222222"/>
+                          </a:solidFill>
+                          <a:latin typeface="Segoe UI"/>
+                        </a:defRPr>
+                      </a:pPr>
+                      <a:r>
+                        <a:rPr sz="1300" b="0">
+                          <a:solidFill>
+                            <a:srgbClr val="222222"/>
+                          </a:solidFill>
+                          <a:latin typeface="Segoe UI"/>
+                        </a:rPr>
+                        <a:t>Template (mẫu chung)</a:t>
+                      </a:r>
+                    </a:p>
+                  </a:txBody>
+                  <a:tcPr>
+                    <a:solidFill>
+                      <a:srgbClr val="EEF2F8"/>
+                    </a:solidFill>
+                  </a:tcPr>
+                </a:tc>
+                <a:tc>
+                  <a:txBody>
+                    <a:bodyPr/>
+                    <a:lstStyle/>
+                    <a:p>
+                      <a:pPr>
+                        <a:defRPr sz="1300" b="0">
+                          <a:solidFill>
+                            <a:srgbClr val="222222"/>
+                          </a:solidFill>
+                          <a:latin typeface="Segoe UI"/>
+                        </a:defRPr>
+                      </a:pPr>
+                      <a:r>
+                        <a:rPr sz="1300" b="0">
+                          <a:solidFill>
+                            <a:srgbClr val="222222"/>
+                          </a:solidFill>
+                          <a:latin typeface="Segoe UI"/>
+                        </a:rPr>
+                        <a:t>22/60 = 36,7% [25,6–49,3%]</a:t>
+                      </a:r>
+                    </a:p>
+                  </a:txBody>
+                  <a:tcPr>
+                    <a:solidFill>
+                      <a:srgbClr val="EEF2F8"/>
+                    </a:solidFill>
+                  </a:tcPr>
+                </a:tc>
+              </a:tr>
+              <a:tr h="384048">
+                <a:tc>
+                  <a:txBody>
+                    <a:bodyPr/>
+                    <a:lstStyle/>
+                    <a:p>
+                      <a:pPr>
+                        <a:defRPr sz="1300" b="0">
+                          <a:solidFill>
+                            <a:srgbClr val="222222"/>
+                          </a:solidFill>
+                          <a:latin typeface="Segoe UI"/>
+                        </a:defRPr>
+                      </a:pPr>
+                      <a:r>
+                        <a:rPr sz="1300" b="0">
+                          <a:solidFill>
+                            <a:srgbClr val="222222"/>
+                          </a:solidFill>
+                          <a:latin typeface="Segoe UI"/>
+                        </a:rPr>
+                        <a:t>Đồng thuận</a:t>
+                      </a:r>
+                    </a:p>
+                  </a:txBody>
+                  <a:tcPr>
+                    <a:solidFill>
+                      <a:srgbClr val="FFFFFF"/>
+                    </a:solidFill>
+                  </a:tcPr>
+                </a:tc>
+                <a:tc>
+                  <a:txBody>
+                    <a:bodyPr/>
+                    <a:lstStyle/>
+                    <a:p>
+                      <a:pPr>
+                        <a:defRPr sz="1300" b="0">
+                          <a:solidFill>
+                            <a:srgbClr val="222222"/>
+                          </a:solidFill>
+                          <a:latin typeface="Segoe UI"/>
+                        </a:defRPr>
+                      </a:pPr>
+                      <a:r>
+                        <a:rPr sz="1300" b="0">
+                          <a:solidFill>
+                            <a:srgbClr val="222222"/>
+                          </a:solidFill>
+                          <a:latin typeface="Segoe UI"/>
+                        </a:rPr>
+                        <a:t>κ = 0,781 (bootstrap 95%: 0,643–0,898)</a:t>
+                      </a:r>
+                    </a:p>
+                  </a:txBody>
+                  <a:tcPr>
+                    <a:solidFill>
+                      <a:srgbClr val="FFFFFF"/>
+                    </a:solidFill>
+                  </a:tcPr>
+                </a:tc>
+              </a:tr>
+            </a:tbl>
+          </a:graphicData>
+        </a:graphic>
+      </p:graphicFrame>
       <p:graphicFrame>
         <p:nvGraphicFramePr>
           <p:cNvPr id="7" name="Table 6"/>
@@ -5996,7 +6293,7 @@
         <p:spPr>
           <a:xfrm>
             <a:off x="548640" y="3429000"/>
-            <a:ext cx="9601200" cy="2881739"/>
+            <a:ext cx="9601200" cy="2887267"/>
           </a:xfrm>
           <a:prstGeom prst="rect">
             <a:avLst/>
@@ -8556,7 +8853,7 @@
                 </a:solidFill>
                 <a:latin typeface="Segoe UI"/>
               </a:rPr>
-              <a:t>•  Landis–Koch chỉ là quy ước diễn giải κ</a:t>
+              <a:t>•  Người chấm sửa phiếu điền sẵn nhãn nháp → κ có thể bị đẩy cao; Landis–Koch chỉ là quy ước</a:t>
             </a:r>
           </a:p>
         </p:txBody>
@@ -9538,7 +9835,7 @@
                 </a:solidFill>
                 <a:latin typeface="Segoe UI"/>
               </a:rPr>
-              <a:t>•  RQ2: hint validity [chưa có số liệu: summary.md]; P95 API 4,9 ms (4,9–5,4) ở 100 người dùng</a:t>
+              <a:t>•  RQ2: hint validity 79/120 = 65,8% [57,0–73,7%]; P95 API 4,9 ms (4,9–5,4) ở 100 người dùng</a:t>
             </a:r>
           </a:p>
           <a:p>
@@ -10263,7 +10560,7 @@
                 </a:solidFill>
                 <a:latin typeface="Segoe UI"/>
               </a:rPr>
-              <a:t>•  Rà soát lời giải (hai thành viên nhóm): đạt chung [chưa có số liệu: summary.md], κ = [chưa có số liệu: summary.md]</a:t>
+              <a:t>•  Rà soát lời giải (hai thành viên nhóm): đạt chung 96/100 = 96,0% [90,2–98,4%], κ = 0,658</a:t>
             </a:r>
           </a:p>
           <a:p>

</xml_diff>